<commit_message>
added documentation and familiarization launcher script
</commit_message>
<xml_diff>
--- a/docs/SMSL-Task-Timing-Diagram.pptx
+++ b/docs/SMSL-Task-Timing-Diagram.pptx
@@ -3457,8 +3457,8 @@
         </p:nvSpPr>
         <p:spPr>
           <a:xfrm>
-            <a:off x="1649719" y="3075088"/>
-            <a:ext cx="437940" cy="334835"/>
+            <a:off x="1706625" y="3075088"/>
+            <a:ext cx="324128" cy="334835"/>
           </a:xfrm>
           <a:prstGeom prst="rect">
             <a:avLst/>
@@ -3474,7 +3474,7 @@
             <a:pPr algn="ctr"/>
             <a:r>
               <a:rPr lang="en-US" sz="788" dirty="0"/>
-              <a:t>Cross</a:t>
+              <a:t>ITG</a:t>
             </a:r>
           </a:p>
           <a:p>
@@ -4454,8 +4454,8 @@
         </p:nvSpPr>
         <p:spPr>
           <a:xfrm>
-            <a:off x="3663339" y="4028448"/>
-            <a:ext cx="802369" cy="196917"/>
+            <a:off x="3825515" y="4028448"/>
+            <a:ext cx="640194" cy="196917"/>
           </a:xfrm>
           <a:prstGeom prst="rect">
             <a:avLst/>
@@ -4506,7 +4506,7 @@
         </p:nvSpPr>
         <p:spPr>
           <a:xfrm>
-            <a:off x="3785912" y="4035490"/>
+            <a:off x="3982704" y="4035141"/>
             <a:ext cx="533345" cy="200055"/>
           </a:xfrm>
           <a:prstGeom prst="rect">
@@ -4652,7 +4652,7 @@
         </p:nvSpPr>
         <p:spPr bwMode="auto">
           <a:xfrm>
-            <a:off x="3816040" y="4904790"/>
+            <a:off x="4010945" y="4904790"/>
             <a:ext cx="218541" cy="172413"/>
           </a:xfrm>
           <a:prstGeom prst="hexagon">
@@ -4956,7 +4956,7 @@
         <p:spPr>
           <a:xfrm>
             <a:off x="2509911" y="4028821"/>
-            <a:ext cx="1133031" cy="196546"/>
+            <a:ext cx="1302087" cy="196546"/>
           </a:xfrm>
           <a:prstGeom prst="rect">
             <a:avLst/>
@@ -5008,7 +5008,7 @@
         <p:spPr>
           <a:xfrm>
             <a:off x="4493425" y="4028820"/>
-            <a:ext cx="1121845" cy="203618"/>
+            <a:ext cx="1338287" cy="203618"/>
           </a:xfrm>
           <a:prstGeom prst="rect">
             <a:avLst/>
@@ -5045,93 +5045,6 @@
           </a:p>
         </p:txBody>
       </p:sp>
-      <p:cxnSp>
-        <p:nvCxnSpPr>
-          <p:cNvPr id="160" name="Straight Connector 159">
-            <a:extLst>
-              <a:ext uri="{FF2B5EF4-FFF2-40B4-BE49-F238E27FC236}">
-                <a16:creationId xmlns:a16="http://schemas.microsoft.com/office/drawing/2014/main" id="{1E22B3E8-CECD-894B-AF5A-A6A2DE86B6C6}"/>
-              </a:ext>
-            </a:extLst>
-          </p:cNvPr>
-          <p:cNvCxnSpPr>
-            <a:cxnSpLocks/>
-          </p:cNvCxnSpPr>
-          <p:nvPr/>
-        </p:nvCxnSpPr>
-        <p:spPr bwMode="auto">
-          <a:xfrm>
-            <a:off x="2007713" y="6049701"/>
-            <a:ext cx="199000" cy="0"/>
-          </a:xfrm>
-          <a:prstGeom prst="line">
-            <a:avLst/>
-          </a:prstGeom>
-          <a:ln w="9525" cap="rnd" cmpd="sng" algn="ctr">
-            <a:solidFill>
-              <a:srgbClr val="C00000"/>
-            </a:solidFill>
-            <a:prstDash val="solid"/>
-            <a:miter lim="800000"/>
-            <a:headEnd type="arrow" w="sm" len="sm"/>
-            <a:tailEnd type="arrow" w="sm" len="sm"/>
-          </a:ln>
-        </p:spPr>
-        <p:style>
-          <a:lnRef idx="0">
-            <a:scrgbClr r="0" g="0" b="0"/>
-          </a:lnRef>
-          <a:fillRef idx="0">
-            <a:scrgbClr r="0" g="0" b="0"/>
-          </a:fillRef>
-          <a:effectRef idx="0">
-            <a:scrgbClr r="0" g="0" b="0"/>
-          </a:effectRef>
-          <a:fontRef idx="minor">
-            <a:schemeClr val="tx1"/>
-          </a:fontRef>
-        </p:style>
-      </p:cxnSp>
-      <p:sp>
-        <p:nvSpPr>
-          <p:cNvPr id="161" name="TextBox 160">
-            <a:extLst>
-              <a:ext uri="{FF2B5EF4-FFF2-40B4-BE49-F238E27FC236}">
-                <a16:creationId xmlns:a16="http://schemas.microsoft.com/office/drawing/2014/main" id="{20BC9A66-36EB-D546-BFC5-F80DD5155240}"/>
-              </a:ext>
-            </a:extLst>
-          </p:cNvPr>
-          <p:cNvSpPr txBox="1"/>
-          <p:nvPr/>
-        </p:nvSpPr>
-        <p:spPr>
-          <a:xfrm>
-            <a:off x="1804988" y="6070602"/>
-            <a:ext cx="631739" cy="507831"/>
-          </a:xfrm>
-          <a:prstGeom prst="rect">
-            <a:avLst/>
-          </a:prstGeom>
-          <a:noFill/>
-        </p:spPr>
-        <p:txBody>
-          <a:bodyPr wrap="square" rtlCol="0">
-            <a:spAutoFit/>
-          </a:bodyPr>
-          <a:lstStyle/>
-          <a:p>
-            <a:pPr algn="ctr"/>
-            <a:r>
-              <a:rPr lang="en-US" sz="900" dirty="0">
-                <a:solidFill>
-                  <a:srgbClr val="C00000"/>
-                </a:solidFill>
-              </a:rPr>
-              <a:t>Syllable duration 0.5s</a:t>
-            </a:r>
-          </a:p>
-        </p:txBody>
-      </p:sp>
       <p:sp>
         <p:nvSpPr>
           <p:cNvPr id="166" name="Rectangle 165">
@@ -5146,8 +5059,8 @@
         </p:nvSpPr>
         <p:spPr>
           <a:xfrm>
-            <a:off x="5635321" y="4028447"/>
-            <a:ext cx="779390" cy="196917"/>
+            <a:off x="5857952" y="4028447"/>
+            <a:ext cx="578653" cy="196917"/>
           </a:xfrm>
           <a:prstGeom prst="rect">
             <a:avLst/>
@@ -5344,7 +5257,7 @@
         </p:nvSpPr>
         <p:spPr bwMode="auto">
           <a:xfrm>
-            <a:off x="5857953" y="4910865"/>
+            <a:off x="6020122" y="4917322"/>
             <a:ext cx="218541" cy="172413"/>
           </a:xfrm>
           <a:prstGeom prst="hexagon">
@@ -6704,7 +6617,7 @@
         </p:nvSpPr>
         <p:spPr>
           <a:xfrm>
-            <a:off x="3526268" y="2189720"/>
+            <a:off x="3705635" y="2211478"/>
             <a:ext cx="1016625" cy="334835"/>
           </a:xfrm>
           <a:prstGeom prst="rect">
@@ -6747,8 +6660,8 @@
         </p:nvSpPr>
         <p:spPr>
           <a:xfrm rot="16200000">
-            <a:off x="3970846" y="2209281"/>
-            <a:ext cx="182407" cy="862750"/>
+            <a:off x="4060530" y="2320722"/>
+            <a:ext cx="182407" cy="683383"/>
           </a:xfrm>
           <a:prstGeom prst="rightBrace">
             <a:avLst/>
@@ -6791,7 +6704,7 @@
         </p:nvSpPr>
         <p:spPr>
           <a:xfrm rot="16200000">
-            <a:off x="3685654" y="2958373"/>
+            <a:off x="3865021" y="2980131"/>
             <a:ext cx="87932" cy="172844"/>
           </a:xfrm>
           <a:prstGeom prst="rightBrace">
@@ -6835,7 +6748,7 @@
         </p:nvSpPr>
         <p:spPr>
           <a:xfrm>
-            <a:off x="3510362" y="2785265"/>
+            <a:off x="3689729" y="2807023"/>
             <a:ext cx="987771" cy="334835"/>
           </a:xfrm>
           <a:prstGeom prst="rect">
@@ -7465,6 +7378,227 @@
             <a:r>
               <a:rPr lang="en-US" sz="788" dirty="0"/>
               <a:t>0.2s</a:t>
+            </a:r>
+          </a:p>
+        </p:txBody>
+      </p:sp>
+      <p:cxnSp>
+        <p:nvCxnSpPr>
+          <p:cNvPr id="204" name="Straight Connector 203">
+            <a:extLst>
+              <a:ext uri="{FF2B5EF4-FFF2-40B4-BE49-F238E27FC236}">
+                <a16:creationId xmlns:a16="http://schemas.microsoft.com/office/drawing/2014/main" id="{78EB058D-67E2-2241-AB14-1D026A83C67B}"/>
+              </a:ext>
+            </a:extLst>
+          </p:cNvPr>
+          <p:cNvCxnSpPr>
+            <a:cxnSpLocks/>
+          </p:cNvCxnSpPr>
+          <p:nvPr/>
+        </p:nvCxnSpPr>
+        <p:spPr>
+          <a:xfrm>
+            <a:off x="3995409" y="3318370"/>
+            <a:ext cx="0" cy="2705100"/>
+          </a:xfrm>
+          <a:prstGeom prst="line">
+            <a:avLst/>
+          </a:prstGeom>
+          <a:ln w="12700">
+            <a:solidFill>
+              <a:schemeClr val="bg1">
+                <a:lumMod val="50000"/>
+              </a:schemeClr>
+            </a:solidFill>
+            <a:prstDash val="sysDot"/>
+          </a:ln>
+        </p:spPr>
+        <p:style>
+          <a:lnRef idx="1">
+            <a:schemeClr val="accent1"/>
+          </a:lnRef>
+          <a:fillRef idx="0">
+            <a:schemeClr val="accent1"/>
+          </a:fillRef>
+          <a:effectRef idx="0">
+            <a:schemeClr val="accent1"/>
+          </a:effectRef>
+          <a:fontRef idx="minor">
+            <a:schemeClr val="tx1"/>
+          </a:fontRef>
+        </p:style>
+      </p:cxnSp>
+      <p:sp>
+        <p:nvSpPr>
+          <p:cNvPr id="206" name="TextBox 205">
+            <a:extLst>
+              <a:ext uri="{FF2B5EF4-FFF2-40B4-BE49-F238E27FC236}">
+                <a16:creationId xmlns:a16="http://schemas.microsoft.com/office/drawing/2014/main" id="{DC123F87-865A-8A4C-B4E2-955007FF00D2}"/>
+              </a:ext>
+            </a:extLst>
+          </p:cNvPr>
+          <p:cNvSpPr txBox="1"/>
+          <p:nvPr/>
+        </p:nvSpPr>
+        <p:spPr>
+          <a:xfrm>
+            <a:off x="3564608" y="3111181"/>
+            <a:ext cx="324128" cy="334835"/>
+          </a:xfrm>
+          <a:prstGeom prst="rect">
+            <a:avLst/>
+          </a:prstGeom>
+          <a:noFill/>
+        </p:spPr>
+        <p:txBody>
+          <a:bodyPr wrap="none" rtlCol="0">
+            <a:spAutoFit/>
+          </a:bodyPr>
+          <a:lstStyle/>
+          <a:p>
+            <a:pPr algn="ctr"/>
+            <a:r>
+              <a:rPr lang="en-US" sz="788" dirty="0"/>
+              <a:t>ITG</a:t>
+            </a:r>
+          </a:p>
+          <a:p>
+            <a:pPr algn="ctr"/>
+            <a:r>
+              <a:rPr lang="en-US" sz="788" dirty="0"/>
+              <a:t>1s</a:t>
+            </a:r>
+          </a:p>
+        </p:txBody>
+      </p:sp>
+      <p:cxnSp>
+        <p:nvCxnSpPr>
+          <p:cNvPr id="208" name="Straight Connector 207">
+            <a:extLst>
+              <a:ext uri="{FF2B5EF4-FFF2-40B4-BE49-F238E27FC236}">
+                <a16:creationId xmlns:a16="http://schemas.microsoft.com/office/drawing/2014/main" id="{E6941D60-3BD3-E341-9DFB-72A6B61C3552}"/>
+              </a:ext>
+            </a:extLst>
+          </p:cNvPr>
+          <p:cNvCxnSpPr>
+            <a:cxnSpLocks/>
+          </p:cNvCxnSpPr>
+          <p:nvPr/>
+        </p:nvCxnSpPr>
+        <p:spPr>
+          <a:xfrm>
+            <a:off x="6020502" y="3284469"/>
+            <a:ext cx="0" cy="2705100"/>
+          </a:xfrm>
+          <a:prstGeom prst="line">
+            <a:avLst/>
+          </a:prstGeom>
+          <a:ln w="12700">
+            <a:solidFill>
+              <a:schemeClr val="bg1">
+                <a:lumMod val="50000"/>
+              </a:schemeClr>
+            </a:solidFill>
+            <a:prstDash val="sysDot"/>
+          </a:ln>
+        </p:spPr>
+        <p:style>
+          <a:lnRef idx="1">
+            <a:schemeClr val="accent1"/>
+          </a:lnRef>
+          <a:fillRef idx="0">
+            <a:schemeClr val="accent1"/>
+          </a:fillRef>
+          <a:effectRef idx="0">
+            <a:schemeClr val="accent1"/>
+          </a:effectRef>
+          <a:fontRef idx="minor">
+            <a:schemeClr val="tx1"/>
+          </a:fontRef>
+        </p:style>
+      </p:cxnSp>
+      <p:sp>
+        <p:nvSpPr>
+          <p:cNvPr id="209" name="TextBox 208">
+            <a:extLst>
+              <a:ext uri="{FF2B5EF4-FFF2-40B4-BE49-F238E27FC236}">
+                <a16:creationId xmlns:a16="http://schemas.microsoft.com/office/drawing/2014/main" id="{98381B82-225B-F84B-8611-7A01F89B95DE}"/>
+              </a:ext>
+            </a:extLst>
+          </p:cNvPr>
+          <p:cNvSpPr txBox="1"/>
+          <p:nvPr/>
+        </p:nvSpPr>
+        <p:spPr>
+          <a:xfrm>
+            <a:off x="5571913" y="3177568"/>
+            <a:ext cx="324128" cy="334835"/>
+          </a:xfrm>
+          <a:prstGeom prst="rect">
+            <a:avLst/>
+          </a:prstGeom>
+          <a:noFill/>
+        </p:spPr>
+        <p:txBody>
+          <a:bodyPr wrap="none" rtlCol="0">
+            <a:spAutoFit/>
+          </a:bodyPr>
+          <a:lstStyle/>
+          <a:p>
+            <a:pPr algn="ctr"/>
+            <a:r>
+              <a:rPr lang="en-US" sz="788" dirty="0"/>
+              <a:t>ITG</a:t>
+            </a:r>
+          </a:p>
+          <a:p>
+            <a:pPr algn="ctr"/>
+            <a:r>
+              <a:rPr lang="en-US" sz="788" dirty="0"/>
+              <a:t>1s</a:t>
+            </a:r>
+          </a:p>
+        </p:txBody>
+      </p:sp>
+      <p:sp>
+        <p:nvSpPr>
+          <p:cNvPr id="211" name="TextBox 210">
+            <a:extLst>
+              <a:ext uri="{FF2B5EF4-FFF2-40B4-BE49-F238E27FC236}">
+                <a16:creationId xmlns:a16="http://schemas.microsoft.com/office/drawing/2014/main" id="{256D7990-FBBC-7146-8D34-C302035569FA}"/>
+              </a:ext>
+            </a:extLst>
+          </p:cNvPr>
+          <p:cNvSpPr txBox="1"/>
+          <p:nvPr/>
+        </p:nvSpPr>
+        <p:spPr>
+          <a:xfrm>
+            <a:off x="7636079" y="3205754"/>
+            <a:ext cx="324128" cy="334835"/>
+          </a:xfrm>
+          <a:prstGeom prst="rect">
+            <a:avLst/>
+          </a:prstGeom>
+          <a:noFill/>
+        </p:spPr>
+        <p:txBody>
+          <a:bodyPr wrap="none" rtlCol="0">
+            <a:spAutoFit/>
+          </a:bodyPr>
+          <a:lstStyle/>
+          <a:p>
+            <a:pPr algn="ctr"/>
+            <a:r>
+              <a:rPr lang="en-US" sz="788" dirty="0"/>
+              <a:t>ITG</a:t>
+            </a:r>
+          </a:p>
+          <a:p>
+            <a:pPr algn="ctr"/>
+            <a:r>
+              <a:rPr lang="en-US" sz="788" dirty="0"/>
+              <a:t>1s</a:t>
             </a:r>
           </a:p>
         </p:txBody>

</xml_diff>